<commit_message>
chore: Synchronize and update all outputs graphics, data tables, and UI screenshots to authentic 2000-2025 Kolhapur version
</commit_message>
<xml_diff>
--- a/presentation/AquaCrop_AI_Crop_Water_Footprint_Presentation.pptx
+++ b/presentation/AquaCrop_AI_Crop_Water_Footprint_Presentation.pptx
@@ -4438,7 +4438,7 @@
         <p:spPr>
           <a:xfrm>
             <a:off x="6355080" y="1828800"/>
-            <a:ext cx="4967935" cy="2980761"/>
+            <a:ext cx="4967935" cy="3161413"/>
           </a:xfrm>
           <a:prstGeom prst="rect">
             <a:avLst/>
@@ -6390,7 +6390,7 @@
         <p:spPr>
           <a:xfrm>
             <a:off x="868680" y="1828800"/>
-            <a:ext cx="5212080" cy="3540205"/>
+            <a:ext cx="5212080" cy="3056385"/>
           </a:xfrm>
           <a:prstGeom prst="rect">
             <a:avLst/>

</xml_diff>